<commit_message>
adding updates sales figs
</commit_message>
<xml_diff>
--- a/images/title.pptx
+++ b/images/title.pptx
@@ -259,7 +259,7 @@
           <a:p>
             <a:fld id="{1E2C8572-9970-0F4D-A39B-B1546E31373A}" type="datetimeFigureOut">
               <a:rPr lang="en-US" smtClean="0"/>
-              <a:t>4/9/26</a:t>
+              <a:t>4/14/26</a:t>
             </a:fld>
             <a:endParaRPr lang="en-US"/>
           </a:p>
@@ -457,7 +457,7 @@
           <a:p>
             <a:fld id="{1E2C8572-9970-0F4D-A39B-B1546E31373A}" type="datetimeFigureOut">
               <a:rPr lang="en-US" smtClean="0"/>
-              <a:t>4/9/26</a:t>
+              <a:t>4/14/26</a:t>
             </a:fld>
             <a:endParaRPr lang="en-US"/>
           </a:p>
@@ -665,7 +665,7 @@
           <a:p>
             <a:fld id="{1E2C8572-9970-0F4D-A39B-B1546E31373A}" type="datetimeFigureOut">
               <a:rPr lang="en-US" smtClean="0"/>
-              <a:t>4/9/26</a:t>
+              <a:t>4/14/26</a:t>
             </a:fld>
             <a:endParaRPr lang="en-US"/>
           </a:p>
@@ -863,7 +863,7 @@
           <a:p>
             <a:fld id="{1E2C8572-9970-0F4D-A39B-B1546E31373A}" type="datetimeFigureOut">
               <a:rPr lang="en-US" smtClean="0"/>
-              <a:t>4/9/26</a:t>
+              <a:t>4/14/26</a:t>
             </a:fld>
             <a:endParaRPr lang="en-US"/>
           </a:p>
@@ -1138,7 +1138,7 @@
           <a:p>
             <a:fld id="{1E2C8572-9970-0F4D-A39B-B1546E31373A}" type="datetimeFigureOut">
               <a:rPr lang="en-US" smtClean="0"/>
-              <a:t>4/9/26</a:t>
+              <a:t>4/14/26</a:t>
             </a:fld>
             <a:endParaRPr lang="en-US"/>
           </a:p>
@@ -1403,7 +1403,7 @@
           <a:p>
             <a:fld id="{1E2C8572-9970-0F4D-A39B-B1546E31373A}" type="datetimeFigureOut">
               <a:rPr lang="en-US" smtClean="0"/>
-              <a:t>4/9/26</a:t>
+              <a:t>4/14/26</a:t>
             </a:fld>
             <a:endParaRPr lang="en-US"/>
           </a:p>
@@ -1815,7 +1815,7 @@
           <a:p>
             <a:fld id="{1E2C8572-9970-0F4D-A39B-B1546E31373A}" type="datetimeFigureOut">
               <a:rPr lang="en-US" smtClean="0"/>
-              <a:t>4/9/26</a:t>
+              <a:t>4/14/26</a:t>
             </a:fld>
             <a:endParaRPr lang="en-US"/>
           </a:p>
@@ -1956,7 +1956,7 @@
           <a:p>
             <a:fld id="{1E2C8572-9970-0F4D-A39B-B1546E31373A}" type="datetimeFigureOut">
               <a:rPr lang="en-US" smtClean="0"/>
-              <a:t>4/9/26</a:t>
+              <a:t>4/14/26</a:t>
             </a:fld>
             <a:endParaRPr lang="en-US"/>
           </a:p>
@@ -2069,7 +2069,7 @@
           <a:p>
             <a:fld id="{1E2C8572-9970-0F4D-A39B-B1546E31373A}" type="datetimeFigureOut">
               <a:rPr lang="en-US" smtClean="0"/>
-              <a:t>4/9/26</a:t>
+              <a:t>4/14/26</a:t>
             </a:fld>
             <a:endParaRPr lang="en-US"/>
           </a:p>
@@ -2380,7 +2380,7 @@
           <a:p>
             <a:fld id="{1E2C8572-9970-0F4D-A39B-B1546E31373A}" type="datetimeFigureOut">
               <a:rPr lang="en-US" smtClean="0"/>
-              <a:t>4/9/26</a:t>
+              <a:t>4/14/26</a:t>
             </a:fld>
             <a:endParaRPr lang="en-US"/>
           </a:p>
@@ -2668,7 +2668,7 @@
           <a:p>
             <a:fld id="{1E2C8572-9970-0F4D-A39B-B1546E31373A}" type="datetimeFigureOut">
               <a:rPr lang="en-US" smtClean="0"/>
-              <a:t>4/9/26</a:t>
+              <a:t>4/14/26</a:t>
             </a:fld>
             <a:endParaRPr lang="en-US"/>
           </a:p>
@@ -2909,7 +2909,7 @@
           <a:p>
             <a:fld id="{1E2C8572-9970-0F4D-A39B-B1546E31373A}" type="datetimeFigureOut">
               <a:rPr lang="en-US" smtClean="0"/>
-              <a:t>4/9/26</a:t>
+              <a:t>4/14/26</a:t>
             </a:fld>
             <a:endParaRPr lang="en-US"/>
           </a:p>
@@ -3404,7 +3404,7 @@
               <a:rPr lang="en-US" sz="3600" dirty="0">
                 <a:latin typeface="Fira Sans Condensed Medium" panose="020B0603050000020004" pitchFamily="34" charset="0"/>
               </a:rPr>
-              <a:t>Looking Ahead While Lagging Behind</a:t>
+              <a:t>Looking Ahead While Lagging Behind (China)</a:t>
             </a:r>
           </a:p>
         </p:txBody>

</xml_diff>